<commit_message>
docs: ship the fixed submission doc, split into five standalone documents
The submission doc gets its cleanup pass baked in: the bordeaux-on-grey
code tokens are now plain black bold David, and every section heading
opens a fresh page via page-break-before on the heading 1 style instead
of a stack of blank paragraphs. Each of the five sections also ships as
its own docx alongside the full document, the deck is refreshed, and the
internal planning notes leave the lecturer-facing repo.

Co-Authored-By: Claude Fable 5 <noreply@anthropic.com>
</commit_message>
<xml_diff>
--- a/docs/DerbyUp-Presentation.pptx
+++ b/docs/DerbyUp-Presentation.pptx
@@ -215,7 +215,7 @@
           <a:p>
             <a:fld id="{66DEF56E-4397-0041-9D65-EBD6922A8087}" type="datetimeFigureOut">
               <a:rPr lang="he-IL" smtClean="0"/>
-              <a:t>ט"ו.אלול.תשפ"ו</a:t>
+              <a:t>י"ז.אלול.תשפ"ו</a:t>
             </a:fld>
             <a:endParaRPr lang="he-IL"/>
           </a:p>
@@ -745,7 +745,7 @@
           <a:p>
             <a:fld id="{5BCAD085-E8A6-8845-BD4E-CB4CCA059FC4}" type="datetimeFigureOut">
               <a:rPr lang="en-US" smtClean="0"/>
-              <a:t>8/28/26</a:t>
+              <a:t>8/30/26</a:t>
             </a:fld>
             <a:endParaRPr lang="en-US"/>
           </a:p>
@@ -913,7 +913,7 @@
           <a:p>
             <a:fld id="{5BCAD085-E8A6-8845-BD4E-CB4CCA059FC4}" type="datetimeFigureOut">
               <a:rPr lang="en-US" smtClean="0"/>
-              <a:t>8/28/26</a:t>
+              <a:t>8/30/26</a:t>
             </a:fld>
             <a:endParaRPr lang="en-US"/>
           </a:p>
@@ -1091,7 +1091,7 @@
           <a:p>
             <a:fld id="{5BCAD085-E8A6-8845-BD4E-CB4CCA059FC4}" type="datetimeFigureOut">
               <a:rPr lang="en-US" smtClean="0"/>
-              <a:t>8/28/26</a:t>
+              <a:t>8/30/26</a:t>
             </a:fld>
             <a:endParaRPr lang="en-US"/>
           </a:p>
@@ -1517,7 +1517,7 @@
           <a:p>
             <a:fld id="{5BCAD085-E8A6-8845-BD4E-CB4CCA059FC4}" type="datetimeFigureOut">
               <a:rPr lang="en-US" smtClean="0"/>
-              <a:t>8/28/26</a:t>
+              <a:t>8/30/26</a:t>
             </a:fld>
             <a:endParaRPr lang="en-US"/>
           </a:p>
@@ -1762,7 +1762,7 @@
           <a:p>
             <a:fld id="{5BCAD085-E8A6-8845-BD4E-CB4CCA059FC4}" type="datetimeFigureOut">
               <a:rPr lang="en-US" smtClean="0"/>
-              <a:t>8/28/26</a:t>
+              <a:t>8/30/26</a:t>
             </a:fld>
             <a:endParaRPr lang="en-US"/>
           </a:p>
@@ -2047,7 +2047,7 @@
           <a:p>
             <a:fld id="{5BCAD085-E8A6-8845-BD4E-CB4CCA059FC4}" type="datetimeFigureOut">
               <a:rPr lang="en-US" smtClean="0"/>
-              <a:t>8/28/26</a:t>
+              <a:t>8/30/26</a:t>
             </a:fld>
             <a:endParaRPr lang="en-US"/>
           </a:p>
@@ -2466,7 +2466,7 @@
           <a:p>
             <a:fld id="{5BCAD085-E8A6-8845-BD4E-CB4CCA059FC4}" type="datetimeFigureOut">
               <a:rPr lang="en-US" smtClean="0"/>
-              <a:t>8/28/26</a:t>
+              <a:t>8/30/26</a:t>
             </a:fld>
             <a:endParaRPr lang="en-US"/>
           </a:p>
@@ -2583,7 +2583,7 @@
           <a:p>
             <a:fld id="{5BCAD085-E8A6-8845-BD4E-CB4CCA059FC4}" type="datetimeFigureOut">
               <a:rPr lang="en-US" smtClean="0"/>
-              <a:t>8/28/26</a:t>
+              <a:t>8/30/26</a:t>
             </a:fld>
             <a:endParaRPr lang="en-US"/>
           </a:p>
@@ -2678,7 +2678,7 @@
           <a:p>
             <a:fld id="{5BCAD085-E8A6-8845-BD4E-CB4CCA059FC4}" type="datetimeFigureOut">
               <a:rPr lang="en-US" smtClean="0"/>
-              <a:t>8/28/26</a:t>
+              <a:t>8/30/26</a:t>
             </a:fld>
             <a:endParaRPr lang="en-US"/>
           </a:p>
@@ -2953,7 +2953,7 @@
           <a:p>
             <a:fld id="{5BCAD085-E8A6-8845-BD4E-CB4CCA059FC4}" type="datetimeFigureOut">
               <a:rPr lang="en-US" smtClean="0"/>
-              <a:t>8/28/26</a:t>
+              <a:t>8/30/26</a:t>
             </a:fld>
             <a:endParaRPr lang="en-US"/>
           </a:p>
@@ -3205,7 +3205,7 @@
           <a:p>
             <a:fld id="{5BCAD085-E8A6-8845-BD4E-CB4CCA059FC4}" type="datetimeFigureOut">
               <a:rPr lang="en-US" smtClean="0"/>
-              <a:t>8/28/26</a:t>
+              <a:t>8/30/26</a:t>
             </a:fld>
             <a:endParaRPr lang="en-US"/>
           </a:p>
@@ -3416,7 +3416,7 @@
           <a:p>
             <a:fld id="{5BCAD085-E8A6-8845-BD4E-CB4CCA059FC4}" type="datetimeFigureOut">
               <a:rPr lang="en-US" smtClean="0"/>
-              <a:t>8/28/26</a:t>
+              <a:t>8/30/26</a:t>
             </a:fld>
             <a:endParaRPr lang="en-US"/>
           </a:p>
@@ -4282,26 +4282,6 @@
               <a:t> </a:t>
             </a:r>
             <a:r>
-              <a:rPr sz="2600" b="1" dirty="0" err="1">
-                <a:solidFill>
-                  <a:srgbClr val="111827"/>
-                </a:solidFill>
-                <a:latin typeface="Heebo"/>
-                <a:cs typeface="Heebo"/>
-              </a:rPr>
-              <a:t>לעבודה</a:t>
-            </a:r>
-            <a:r>
-              <a:rPr sz="2600" b="1" dirty="0">
-                <a:solidFill>
-                  <a:srgbClr val="111827"/>
-                </a:solidFill>
-                <a:latin typeface="Heebo"/>
-                <a:cs typeface="Heebo"/>
-              </a:rPr>
-              <a:t> </a:t>
-            </a:r>
-            <a:r>
               <a:rPr lang="he-IL" sz="2600" b="1" dirty="0">
                 <a:solidFill>
                   <a:srgbClr val="111827"/>
@@ -4401,14 +4381,14 @@
               </a:spcAft>
             </a:pPr>
             <a:r>
-              <a:rPr sz="1250" b="1" dirty="0" err="1">
-                <a:solidFill>
-                  <a:srgbClr val="111827"/>
-                </a:solidFill>
-                <a:latin typeface="Heebo"/>
-                <a:cs typeface="Heebo"/>
-              </a:rPr>
-              <a:t>הבעיה</a:t>
+              <a:rPr lang="he-IL" sz="1250" b="1" dirty="0">
+                <a:solidFill>
+                  <a:srgbClr val="111827"/>
+                </a:solidFill>
+                <a:latin typeface="Heebo"/>
+                <a:cs typeface="Heebo"/>
+              </a:rPr>
+              <a:t>הבעיה – למה יש ערך עסקי?</a:t>
             </a:r>
             <a:endParaRPr sz="1250" b="1" dirty="0">
               <a:solidFill>
@@ -5012,6 +4992,16 @@
               </a:rPr>
               <a:t>הפתרון</a:t>
             </a:r>
+            <a:r>
+              <a:rPr lang="he-IL" sz="1250" b="1" dirty="0">
+                <a:solidFill>
+                  <a:srgbClr val="111827"/>
+                </a:solidFill>
+                <a:latin typeface="Heebo"/>
+                <a:cs typeface="Heebo"/>
+              </a:rPr>
+              <a:t> – תהליכים מרכזיים במוצר</a:t>
+            </a:r>
             <a:endParaRPr sz="1250" b="1" dirty="0">
               <a:solidFill>
                 <a:srgbClr val="111827"/>
@@ -5407,7 +5397,7 @@
                 <a:latin typeface="Heebo"/>
                 <a:cs typeface="Heebo"/>
               </a:rPr>
-              <a:t> לגישור הפער למשתמשים פחות מעורבים</a:t>
+              <a:t> לעצות ״מקצועיות״ לניחושים</a:t>
             </a:r>
             <a:endParaRPr sz="1200" b="0" dirty="0">
               <a:solidFill>
@@ -6294,17 +6284,7 @@
                 <a:latin typeface="Heebo"/>
                 <a:cs typeface="Heebo"/>
               </a:rPr>
-              <a:t>פרטיות וציבוריות · 3 </a:t>
-            </a:r>
-            <a:r>
-              <a:rPr sz="1600" b="0" dirty="0" err="1">
-                <a:solidFill>
-                  <a:srgbClr val="111827"/>
-                </a:solidFill>
-                <a:latin typeface="Heebo"/>
-                <a:cs typeface="Heebo"/>
-              </a:rPr>
-              <a:t>ניחושים</a:t>
+              <a:t>פרטיות וציבוריות · 3 שאלות ניחוש</a:t>
             </a:r>
             <a:r>
               <a:rPr sz="1600" b="0" dirty="0">
@@ -8645,7 +8625,7 @@
         </p:nvSpPr>
         <p:spPr>
           <a:xfrm>
-            <a:off x="6233009" y="1944275"/>
+            <a:off x="6233007" y="1674309"/>
             <a:ext cx="5455767" cy="1484725"/>
           </a:xfrm>
           <a:prstGeom prst="roundRect">
@@ -8833,7 +8813,7 @@
         </p:nvSpPr>
         <p:spPr>
           <a:xfrm>
-            <a:off x="502922" y="1944276"/>
+            <a:off x="502920" y="1674310"/>
             <a:ext cx="5455767" cy="907307"/>
           </a:xfrm>
           <a:prstGeom prst="roundRect">
@@ -8955,7 +8935,7 @@
         </p:nvSpPr>
         <p:spPr>
           <a:xfrm>
-            <a:off x="6233009" y="3937197"/>
+            <a:off x="6233007" y="3667231"/>
             <a:ext cx="5455767" cy="1484725"/>
           </a:xfrm>
           <a:prstGeom prst="roundRect">
@@ -9173,7 +9153,7 @@
         </p:nvSpPr>
         <p:spPr>
           <a:xfrm>
-            <a:off x="502921" y="3229446"/>
+            <a:off x="502919" y="2959480"/>
             <a:ext cx="5455767" cy="907307"/>
           </a:xfrm>
           <a:prstGeom prst="roundRect">
@@ -9317,7 +9297,7 @@
         </p:nvSpPr>
         <p:spPr>
           <a:xfrm>
-            <a:off x="502920" y="4514615"/>
+            <a:off x="502918" y="4244649"/>
             <a:ext cx="5455767" cy="907307"/>
           </a:xfrm>
           <a:prstGeom prst="roundRect">
@@ -9494,66 +9474,6 @@
                 <a:cs typeface="Heebo"/>
               </a:rPr>
               <a:t>ארכיטקטורה</a:t>
-            </a:r>
-            <a:r>
-              <a:rPr sz="2600" b="1" dirty="0">
-                <a:solidFill>
-                  <a:srgbClr val="111827"/>
-                </a:solidFill>
-                <a:latin typeface="Heebo"/>
-                <a:cs typeface="Heebo"/>
-              </a:rPr>
-              <a:t> - </a:t>
-            </a:r>
-            <a:r>
-              <a:rPr sz="2600" b="1" dirty="0" err="1">
-                <a:solidFill>
-                  <a:srgbClr val="111827"/>
-                </a:solidFill>
-                <a:latin typeface="Heebo"/>
-                <a:cs typeface="Heebo"/>
-              </a:rPr>
-              <a:t>הכול</a:t>
-            </a:r>
-            <a:r>
-              <a:rPr sz="2600" b="1" dirty="0">
-                <a:solidFill>
-                  <a:srgbClr val="111827"/>
-                </a:solidFill>
-                <a:latin typeface="Heebo"/>
-                <a:cs typeface="Heebo"/>
-              </a:rPr>
-              <a:t> </a:t>
-            </a:r>
-            <a:r>
-              <a:rPr sz="2600" b="1" dirty="0" err="1">
-                <a:solidFill>
-                  <a:srgbClr val="111827"/>
-                </a:solidFill>
-                <a:latin typeface="Heebo"/>
-                <a:cs typeface="Heebo"/>
-              </a:rPr>
-              <a:t>בצד</a:t>
-            </a:r>
-            <a:r>
-              <a:rPr sz="2600" b="1" dirty="0">
-                <a:solidFill>
-                  <a:srgbClr val="111827"/>
-                </a:solidFill>
-                <a:latin typeface="Heebo"/>
-                <a:cs typeface="Heebo"/>
-              </a:rPr>
-              <a:t> </a:t>
-            </a:r>
-            <a:r>
-              <a:rPr sz="2600" b="1" dirty="0" err="1">
-                <a:solidFill>
-                  <a:srgbClr val="111827"/>
-                </a:solidFill>
-                <a:latin typeface="Heebo"/>
-                <a:cs typeface="Heebo"/>
-              </a:rPr>
-              <a:t>השרת</a:t>
             </a:r>
             <a:endParaRPr sz="2600" b="1" dirty="0">
               <a:solidFill>
@@ -9699,104 +9619,14 @@
               </a:spcAft>
             </a:pPr>
             <a:r>
-              <a:rPr sz="950" b="0" dirty="0">
-                <a:solidFill>
-                  <a:srgbClr val="5A6473"/>
-                </a:solidFill>
-                <a:latin typeface="Heebo"/>
-                <a:cs typeface="Heebo"/>
-              </a:rPr>
-              <a:t>12 </a:t>
-            </a:r>
-            <a:r>
-              <a:rPr sz="950" b="0" dirty="0" err="1">
-                <a:solidFill>
-                  <a:srgbClr val="5A6473"/>
-                </a:solidFill>
-                <a:latin typeface="Heebo"/>
-                <a:cs typeface="Heebo"/>
-              </a:rPr>
-              <a:t>ליבה</a:t>
-            </a:r>
-            <a:r>
-              <a:rPr sz="950" b="0" dirty="0">
-                <a:solidFill>
-                  <a:srgbClr val="5A6473"/>
-                </a:solidFill>
-                <a:latin typeface="Heebo"/>
-                <a:cs typeface="Heebo"/>
-              </a:rPr>
-              <a:t> + 6 </a:t>
-            </a:r>
-            <a:r>
-              <a:rPr sz="950" b="0" dirty="0" err="1">
-                <a:solidFill>
-                  <a:srgbClr val="5A6473"/>
-                </a:solidFill>
-                <a:latin typeface="Heebo"/>
-                <a:cs typeface="Heebo"/>
-              </a:rPr>
-              <a:t>של</a:t>
-            </a:r>
-            <a:r>
-              <a:rPr sz="950" b="0" dirty="0">
-                <a:solidFill>
-                  <a:srgbClr val="5A6473"/>
-                </a:solidFill>
-                <a:latin typeface="Heebo"/>
-                <a:cs typeface="Heebo"/>
-              </a:rPr>
-              <a:t> </a:t>
-            </a:r>
-            <a:r>
-              <a:rPr sz="950" b="0" dirty="0" err="1">
-                <a:solidFill>
-                  <a:srgbClr val="5A6473"/>
-                </a:solidFill>
-                <a:latin typeface="Heebo"/>
-                <a:cs typeface="Heebo"/>
-              </a:rPr>
-              <a:t>היועץ</a:t>
-            </a:r>
-            <a:r>
-              <a:rPr sz="950" b="0" dirty="0">
-                <a:solidFill>
-                  <a:srgbClr val="5A6473"/>
-                </a:solidFill>
-                <a:latin typeface="Heebo"/>
-                <a:cs typeface="Heebo"/>
-              </a:rPr>
-              <a:t>, </a:t>
-            </a:r>
-            <a:r>
-              <a:rPr sz="950" b="0" dirty="0" err="1">
-                <a:solidFill>
-                  <a:srgbClr val="5A6473"/>
-                </a:solidFill>
-                <a:latin typeface="Heebo"/>
-                <a:cs typeface="Heebo"/>
-              </a:rPr>
-              <a:t>בהפרדה</a:t>
-            </a:r>
-            <a:r>
-              <a:rPr sz="950" b="0" dirty="0">
-                <a:solidFill>
-                  <a:srgbClr val="5A6473"/>
-                </a:solidFill>
-                <a:latin typeface="Heebo"/>
-                <a:cs typeface="Heebo"/>
-              </a:rPr>
-              <a:t> </a:t>
-            </a:r>
-            <a:r>
-              <a:rPr sz="950" b="0" dirty="0" err="1">
-                <a:solidFill>
-                  <a:srgbClr val="5A6473"/>
-                </a:solidFill>
-                <a:latin typeface="Heebo"/>
-                <a:cs typeface="Heebo"/>
-              </a:rPr>
-              <a:t>מכוונת</a:t>
+              <a:rPr lang="he-IL" sz="950" b="0" dirty="0">
+                <a:solidFill>
+                  <a:srgbClr val="5A6473"/>
+                </a:solidFill>
+                <a:latin typeface="Heebo"/>
+                <a:cs typeface="Heebo"/>
+              </a:rPr>
+              <a:t>12 ליבה + 6 של היועץ בהפרדה מכוונת</a:t>
             </a:r>
             <a:endParaRPr sz="950" b="0" dirty="0">
               <a:solidFill>
@@ -11828,73 +11658,6 @@
           <a:chExt cx="0" cy="0"/>
         </a:xfrm>
       </p:grpSpPr>
-      <p:pic>
-        <p:nvPicPr>
-          <p:cNvPr id="2" name="Picture 1" descr="logo.png"/>
-          <p:cNvPicPr>
-            <a:picLocks noChangeAspect="1"/>
-          </p:cNvPicPr>
-          <p:nvPr/>
-        </p:nvPicPr>
-        <p:blipFill>
-          <a:blip r:embed="rId2"/>
-          <a:stretch>
-            <a:fillRect/>
-          </a:stretch>
-        </p:blipFill>
-        <p:spPr>
-          <a:xfrm>
-            <a:off x="502920" y="237744"/>
-            <a:ext cx="310896" cy="310896"/>
-          </a:xfrm>
-          <a:prstGeom prst="rect">
-            <a:avLst/>
-          </a:prstGeom>
-        </p:spPr>
-      </p:pic>
-      <p:sp>
-        <p:nvSpPr>
-          <p:cNvPr id="3" name="TextBox 2"/>
-          <p:cNvSpPr txBox="1"/>
-          <p:nvPr/>
-        </p:nvSpPr>
-        <p:spPr>
-          <a:xfrm>
-            <a:off x="886968" y="246888"/>
-            <a:ext cx="1463040" cy="320040"/>
-          </a:xfrm>
-          <a:prstGeom prst="rect">
-            <a:avLst/>
-          </a:prstGeom>
-          <a:noFill/>
-        </p:spPr>
-        <p:txBody>
-          <a:bodyPr wrap="square" lIns="0" tIns="0" rIns="0" bIns="0" anchor="t">
-            <a:spAutoFit/>
-          </a:bodyPr>
-          <a:lstStyle/>
-          <a:p>
-            <a:pPr algn="l">
-              <a:spcBef>
-                <a:spcPts val="0"/>
-              </a:spcBef>
-              <a:spcAft>
-                <a:spcPts val="400"/>
-              </a:spcAft>
-            </a:pPr>
-            <a:r>
-              <a:rPr sz="1300" b="1">
-                <a:solidFill>
-                  <a:srgbClr val="111827"/>
-                </a:solidFill>
-                <a:latin typeface="Heebo"/>
-                <a:cs typeface="Heebo"/>
-              </a:rPr>
-              <a:t>DerbyUp</a:t>
-            </a:r>
-          </a:p>
-        </p:txBody>
-      </p:sp>
       <p:sp>
         <p:nvSpPr>
           <p:cNvPr id="5" name="TextBox 4"/>
@@ -12885,28 +12648,25 @@
                 <a:latin typeface="Heebo"/>
                 <a:cs typeface="Heebo"/>
               </a:rPr>
-              <a:t>מחיקת עונות ישנות</a:t>
-            </a:r>
-          </a:p>
-          <a:p>
-            <a:pPr algn="ctr" rtl="1">
-              <a:spcBef>
-                <a:spcPts val="0"/>
-              </a:spcBef>
-              <a:spcAft>
-                <a:spcPts val="300"/>
-              </a:spcAft>
-            </a:pPr>
-            <a:r>
-              <a:rPr lang="he-IL" sz="1100" dirty="0">
-                <a:solidFill>
-                  <a:srgbClr val="111827"/>
-                </a:solidFill>
-                <a:latin typeface="Heebo"/>
-                <a:cs typeface="Heebo"/>
-              </a:rPr>
-              <a:t>פריסת שרתים רב אזורית</a:t>
-            </a:r>
+              <a:t>מחיקת </a:t>
+            </a:r>
+            <a:r>
+              <a:rPr lang="he-IL" sz="1100">
+                <a:solidFill>
+                  <a:srgbClr val="111827"/>
+                </a:solidFill>
+                <a:latin typeface="Heebo"/>
+                <a:cs typeface="Heebo"/>
+              </a:rPr>
+              <a:t>עונות ישנות</a:t>
+            </a:r>
+            <a:endParaRPr lang="he-IL" sz="1100" dirty="0">
+              <a:solidFill>
+                <a:srgbClr val="111827"/>
+              </a:solidFill>
+              <a:latin typeface="Heebo"/>
+              <a:cs typeface="Heebo"/>
+            </a:endParaRPr>
           </a:p>
         </p:txBody>
       </p:sp>

</xml_diff>